<commit_message>
Update Slime Volleyball MARL.pptx
</commit_message>
<xml_diff>
--- a/docs/Slime Volleyball MARL.pptx
+++ b/docs/Slime Volleyball MARL.pptx
@@ -5,17 +5,18 @@
     <p:sldMasterId id="2147483648" r:id="rId4"/>
   </p:sldMasterIdLst>
   <p:notesMasterIdLst>
-    <p:notesMasterId r:id="rId10"/>
+    <p:notesMasterId r:id="rId11"/>
   </p:notesMasterIdLst>
   <p:handoutMasterIdLst>
-    <p:handoutMasterId r:id="rId11"/>
+    <p:handoutMasterId r:id="rId12"/>
   </p:handoutMasterIdLst>
   <p:sldIdLst>
     <p:sldId id="322" r:id="rId5"/>
     <p:sldId id="325" r:id="rId6"/>
     <p:sldId id="323" r:id="rId7"/>
-    <p:sldId id="324" r:id="rId8"/>
-    <p:sldId id="310" r:id="rId9"/>
+    <p:sldId id="326" r:id="rId8"/>
+    <p:sldId id="324" r:id="rId9"/>
+    <p:sldId id="310" r:id="rId10"/>
   </p:sldIdLst>
   <p:sldSz cx="12192000" cy="6858000"/>
   <p:notesSz cx="6858000" cy="9144000"/>
@@ -225,7 +226,7 @@
           <a:p>
             <a:fld id="{4BE6205E-B305-4B90-9534-3C5E99A0275E}" type="datetimeFigureOut">
               <a:rPr lang="en-US" smtClean="0"/>
-              <a:t>5/18/2026</a:t>
+              <a:t>6/7/2026</a:t>
             </a:fld>
             <a:endParaRPr lang="en-US" dirty="0"/>
           </a:p>
@@ -402,7 +403,7 @@
           <a:p>
             <a:fld id="{233722F1-E430-42A1-A473-1759336AECCE}" type="datetimeFigureOut">
               <a:rPr lang="en-US" smtClean="0"/>
-              <a:t>5/18/2026</a:t>
+              <a:t>6/7/2026</a:t>
             </a:fld>
             <a:endParaRPr lang="en-US" dirty="0"/>
           </a:p>
@@ -5959,8 +5960,8 @@
         </p:nvSpPr>
         <p:spPr>
           <a:xfrm>
-            <a:off x="2864498" y="2312646"/>
-            <a:ext cx="7277877" cy="1200329"/>
+            <a:off x="2125825" y="2404980"/>
+            <a:ext cx="9060024" cy="1200329"/>
           </a:xfrm>
         </p:spPr>
         <p:txBody>
@@ -5971,14 +5972,14 @@
           <a:p>
             <a:pPr algn="ctr"/>
             <a:r>
+              <a:rPr lang="pl-PL" dirty="0"/>
+              <a:t>Uczenie ze wzmocnieniem w środowisku </a:t>
+            </a:r>
+            <a:r>
               <a:rPr lang="en-US" noProof="0" dirty="0"/>
-              <a:t>Slime Volleyball</a:t>
-            </a:r>
-            <a:r>
-              <a:rPr lang="pl-PL" noProof="0" dirty="0"/>
-              <a:t> MARL</a:t>
-            </a:r>
-            <a:endParaRPr lang="en-US" noProof="0" dirty="0"/>
+              <a:t>Slime Volleyball </a:t>
+            </a:r>
+            <a:endParaRPr lang="pl-PL" noProof="0" dirty="0"/>
           </a:p>
         </p:txBody>
       </p:sp>
@@ -5996,8 +5997,8 @@
         </p:nvSpPr>
         <p:spPr>
           <a:xfrm>
-            <a:off x="2864498" y="3605309"/>
-            <a:ext cx="7277878" cy="1015663"/>
+            <a:off x="3016898" y="3913085"/>
+            <a:ext cx="7277878" cy="400110"/>
           </a:xfrm>
           <a:prstGeom prst="rect">
             <a:avLst/>
@@ -6018,27 +6019,7 @@
                 </a:solidFill>
                 <a:latin typeface="+mj-lt"/>
               </a:rPr>
-              <a:t>Celem jest stworzenie agenta opartego na uczeniu wieloagentowym, </a:t>
-            </a:r>
-            <a:r>
-              <a:rPr lang="pl-PL" sz="2000" dirty="0">
-                <a:solidFill>
-                  <a:schemeClr val="bg1"/>
-                </a:solidFill>
-                <a:latin typeface="+mj-lt"/>
-                <a:ea typeface="Calibri" panose="020F0502020204030204" pitchFamily="34" charset="0"/>
-                <a:cs typeface="Calibri" panose="020F0502020204030204" pitchFamily="34" charset="0"/>
-              </a:rPr>
-              <a:t>zdolnego</a:t>
-            </a:r>
-            <a:r>
-              <a:rPr lang="pl-PL" sz="2000" dirty="0">
-                <a:solidFill>
-                  <a:schemeClr val="bg1"/>
-                </a:solidFill>
-                <a:latin typeface="+mj-lt"/>
-              </a:rPr>
-              <a:t> do nauki i adaptacji w dynamicznym środowisku gry w siatkówkę 2D.</a:t>
+              <a:t>Ewolucja oraz algorytm PPO w grze 2D</a:t>
             </a:r>
             <a:endParaRPr lang="en-US" sz="2000" dirty="0">
               <a:solidFill>
@@ -6163,13 +6144,10 @@
           <a:lstStyle/>
           <a:p>
             <a:r>
-              <a:rPr lang="pl-PL" b="1" noProof="0" dirty="0"/>
-              <a:t>Środowisko </a:t>
-            </a:r>
-            <a:r>
-              <a:rPr lang="pl-PL" b="1" i="1" noProof="0" dirty="0"/>
-              <a:t>SlimeVolleyGym</a:t>
-            </a:r>
+              <a:rPr lang="pl-PL" b="1" dirty="0"/>
+              <a:t>Środowisko i zasady gry</a:t>
+            </a:r>
+            <a:endParaRPr lang="pl-PL" b="1" i="1" noProof="0" dirty="0"/>
           </a:p>
         </p:txBody>
       </p:sp>
@@ -6215,9 +6193,12 @@
             <a:pPr marL="0" indent="0">
               <a:buNone/>
             </a:pPr>
-            <a:endParaRPr lang="pl-PL" sz="1600" dirty="0">
-              <a:latin typeface="Tisa Offc Serif Pro" panose="02010504030101020102" pitchFamily="2" charset="0"/>
-            </a:endParaRPr>
+            <a:r>
+              <a:rPr lang="pl-PL" sz="1600" dirty="0">
+                <a:latin typeface="Tisa Offc Serif Pro" panose="02010504030101020102" pitchFamily="2" charset="0"/>
+              </a:rPr>
+              <a:t>Środowisko zostało wzbogacone o nagrodę o wartości 0.01 za przebicie piłki nad siatką oraz limit 3 odbić pod rząd przez jednego agenta.</a:t>
+            </a:r>
           </a:p>
           <a:p>
             <a:r>
@@ -6246,23 +6227,6 @@
               </a:rPr>
               <a:t>: 3 bity (Przód, Tył, Skok).</a:t>
             </a:r>
-          </a:p>
-          <a:p>
-            <a:r>
-              <a:rPr lang="pl-PL" sz="1600" b="1" dirty="0">
-                <a:latin typeface="Tisa Offc Serif Pro" panose="02010504030101020102" pitchFamily="2" charset="0"/>
-              </a:rPr>
-              <a:t>Agent vs Agent</a:t>
-            </a:r>
-            <a:r>
-              <a:rPr lang="pl-PL" sz="1600" dirty="0">
-                <a:latin typeface="Tisa Offc Serif Pro" panose="02010504030101020102" pitchFamily="2" charset="0"/>
-              </a:rPr>
-              <a:t>: Natywne wsparcie dla rywalizacji MARL.</a:t>
-            </a:r>
-            <a:endParaRPr lang="pl-PL" sz="1600" noProof="0" dirty="0">
-              <a:latin typeface="Tisa Offc Serif Pro" panose="02010504030101020102" pitchFamily="2" charset="0"/>
-            </a:endParaRPr>
           </a:p>
         </p:txBody>
       </p:sp>
@@ -6444,7 +6408,7 @@
               <a:rPr lang="pl-PL" sz="2400" b="1" dirty="0">
                 <a:latin typeface="Tisa Offc Serif Pro" panose="02010504030101020102" pitchFamily="2" charset="0"/>
               </a:rPr>
-              <a:t>Algorytm IPPO</a:t>
+              <a:t>Algorytm PPO</a:t>
             </a:r>
           </a:p>
           <a:p>
@@ -6455,43 +6419,7 @@
               <a:rPr lang="pl-PL" sz="1600" dirty="0">
                 <a:latin typeface="Tisa Offc Serif Pro" panose="02010504030101020102" pitchFamily="2" charset="0"/>
               </a:rPr>
-              <a:t>Independent </a:t>
-            </a:r>
-            <a:r>
-              <a:rPr lang="pl-PL" sz="1600" dirty="0" err="1">
-                <a:latin typeface="Tisa Offc Serif Pro" panose="02010504030101020102" pitchFamily="2" charset="0"/>
-              </a:rPr>
-              <a:t>Proximal</a:t>
-            </a:r>
-            <a:r>
-              <a:rPr lang="pl-PL" sz="1600" dirty="0">
-                <a:latin typeface="Tisa Offc Serif Pro" panose="02010504030101020102" pitchFamily="2" charset="0"/>
-              </a:rPr>
-              <a:t> Policy </a:t>
-            </a:r>
-            <a:r>
-              <a:rPr lang="pl-PL" sz="1600" dirty="0" err="1">
-                <a:latin typeface="Tisa Offc Serif Pro" panose="02010504030101020102" pitchFamily="2" charset="0"/>
-              </a:rPr>
-              <a:t>Optimization</a:t>
-            </a:r>
-            <a:r>
-              <a:rPr lang="pl-PL" sz="1600" dirty="0">
-                <a:latin typeface="Tisa Offc Serif Pro" panose="02010504030101020102" pitchFamily="2" charset="0"/>
-              </a:rPr>
-              <a:t> to wariant popularnego algorytmu uczenia ze wzmocnieniem PPO, dostosowany do środowisk </a:t>
-            </a:r>
-            <a:r>
-              <a:rPr lang="pl-PL" sz="1600" dirty="0" err="1">
-                <a:latin typeface="Tisa Offc Serif Pro" panose="02010504030101020102" pitchFamily="2" charset="0"/>
-              </a:rPr>
-              <a:t>wieloagentowych</a:t>
-            </a:r>
-            <a:r>
-              <a:rPr lang="pl-PL" sz="1600" dirty="0">
-                <a:latin typeface="Tisa Offc Serif Pro" panose="02010504030101020102" pitchFamily="2" charset="0"/>
-              </a:rPr>
-              <a:t>. W tym podejściu każdy agent uczy się całkowicie niezależnie i optymalizuje własną strategię, traktując drugiego gracza po prostu jako element dynamicznie zmieniającego się otoczenia.</a:t>
+              <a:t>Stabilna metoda gradientowa optymalizującą politykę agenta w trakcie gry. Działa ona dobrze w tego typu problemach dzięki mechanizmowi przycinania funkcji celu, co zapobiega zbyt agresywnym aktualizacjom wag.</a:t>
             </a:r>
             <a:endParaRPr lang="pl-PL" sz="1600" noProof="0" dirty="0">
               <a:latin typeface="Tisa Offc Serif Pro" panose="02010504030101020102" pitchFamily="2" charset="0"/>
@@ -6743,7 +6671,7 @@
               <a:rPr lang="pl-PL" sz="2400" b="1" dirty="0">
                 <a:latin typeface="Tisa Offc Serif Pro" panose="02010504030101020102" pitchFamily="2" charset="0"/>
               </a:rPr>
-              <a:t>Self-Play</a:t>
+              <a:t>Polityka ekspercka</a:t>
             </a:r>
           </a:p>
           <a:p>
@@ -6754,7 +6682,7 @@
               <a:rPr lang="pl-PL" sz="1600" dirty="0">
                 <a:latin typeface="Tisa Offc Serif Pro" panose="02010504030101020102" pitchFamily="2" charset="0"/>
               </a:rPr>
-              <a:t>Dzięki technice treningowa, w której agent nie uczy się poprzez grę ze stałym botem, lecz rywalizuje ze swoimi aktualnymi i wcześniejszymi wersjami poziom trudności rośnie naturalnie wraz z umiejętnościami agenta, zmuszając go do ciągłego odkrywania nowych strategii.</a:t>
+              <a:t>Agent uczy się poprzez bezpośrednią rywalizację z wbudowanym, wytrenowanym genetycznie ekspertem, małą 120 parametrową rekurencyjną siecią neuronową wytrenowaną metodą self-play.</a:t>
             </a:r>
           </a:p>
         </p:txBody>
@@ -6775,8 +6703,8 @@
         </p:nvSpPr>
         <p:spPr>
           <a:xfrm>
-            <a:off x="7831916" y="2108720"/>
-            <a:ext cx="2982264" cy="4119463"/>
+            <a:off x="7831915" y="2108720"/>
+            <a:ext cx="3066239" cy="4119463"/>
           </a:xfrm>
           <a:prstGeom prst="rect">
             <a:avLst/>
@@ -6973,7 +6901,7 @@
               <a:rPr lang="pl-PL" sz="2400" b="1" dirty="0">
                 <a:latin typeface="Tisa Offc Serif Pro" panose="02010504030101020102" pitchFamily="2" charset="0"/>
               </a:rPr>
-              <a:t>Kształtowanie nagród</a:t>
+              <a:t>Ewolucja</a:t>
             </a:r>
           </a:p>
           <a:p>
@@ -6984,7 +6912,7 @@
               <a:rPr lang="pl-PL" sz="1600" dirty="0">
                 <a:latin typeface="Tisa Offc Serif Pro" panose="02010504030101020102" pitchFamily="2" charset="0"/>
               </a:rPr>
-              <a:t>Przyznawanie agentowi mniejszych, pomocniczych punktów za pożądane zachowania, na przykład samo odbicie piłki zapewnia częstszą informację zwrotną, co może przyspieszać proces nauki od podstaw, gdy zdobycie głównego punktu za wygranie wymiany jest początkowo zbyt trudne.</a:t>
+              <a:t>Biblioteka AgileRL dostarcza ewolucyjną metodę optymalizacji parametrów w trakcie uczenia. Mutują hiperparametry algorytmu oraz sama architektura sieci neuronowej.</a:t>
             </a:r>
           </a:p>
         </p:txBody>
@@ -7003,6 +6931,511 @@
 </file>
 
 <file path=ppt/slides/slide4.xml><?xml version="1.0" encoding="utf-8"?>
+<p:sld xmlns:a="http://schemas.openxmlformats.org/drawingml/2006/main" xmlns:r="http://schemas.openxmlformats.org/officeDocument/2006/relationships" xmlns:p="http://schemas.openxmlformats.org/presentationml/2006/main">
+  <p:cSld>
+    <p:spTree>
+      <p:nvGrpSpPr>
+        <p:cNvPr id="1" name=""/>
+        <p:cNvGrpSpPr/>
+        <p:nvPr/>
+      </p:nvGrpSpPr>
+      <p:grpSpPr>
+        <a:xfrm>
+          <a:off x="0" y="0"/>
+          <a:ext cx="0" cy="0"/>
+          <a:chOff x="0" y="0"/>
+          <a:chExt cx="0" cy="0"/>
+        </a:xfrm>
+      </p:grpSpPr>
+      <p:sp>
+        <p:nvSpPr>
+          <p:cNvPr id="2" name="Title 1">
+            <a:extLst>
+              <a:ext uri="{FF2B5EF4-FFF2-40B4-BE49-F238E27FC236}">
+                <a16:creationId xmlns:a16="http://schemas.microsoft.com/office/drawing/2014/main" id="{88BF9EB1-00F6-2CC0-7B4A-A437B9AA71AA}"/>
+              </a:ext>
+            </a:extLst>
+          </p:cNvPr>
+          <p:cNvSpPr>
+            <a:spLocks noGrp="1"/>
+          </p:cNvSpPr>
+          <p:nvPr>
+            <p:ph type="title"/>
+          </p:nvPr>
+        </p:nvSpPr>
+        <p:spPr/>
+        <p:txBody>
+          <a:bodyPr/>
+          <a:lstStyle/>
+          <a:p>
+            <a:r>
+              <a:rPr lang="pl-PL" dirty="0"/>
+              <a:t>Przebieg procesu uczenia algorytmu PPO</a:t>
+            </a:r>
+            <a:endParaRPr lang="en-US" dirty="0"/>
+          </a:p>
+        </p:txBody>
+      </p:sp>
+      <p:pic>
+        <p:nvPicPr>
+          <p:cNvPr id="6" name="Content Placeholder 5">
+            <a:extLst>
+              <a:ext uri="{FF2B5EF4-FFF2-40B4-BE49-F238E27FC236}">
+                <a16:creationId xmlns:a16="http://schemas.microsoft.com/office/drawing/2014/main" id="{4F1516C0-F976-C49C-9E85-55A526771C8E}"/>
+              </a:ext>
+            </a:extLst>
+          </p:cNvPr>
+          <p:cNvPicPr>
+            <a:picLocks noGrp="1" noChangeAspect="1"/>
+          </p:cNvPicPr>
+          <p:nvPr>
+            <p:ph sz="quarter" idx="12"/>
+          </p:nvPr>
+        </p:nvPicPr>
+        <p:blipFill>
+          <a:blip r:embed="rId2"/>
+          <a:stretch>
+            <a:fillRect/>
+          </a:stretch>
+        </p:blipFill>
+        <p:spPr>
+          <a:xfrm>
+            <a:off x="4462184" y="1931437"/>
+            <a:ext cx="7231224" cy="4338734"/>
+          </a:xfrm>
+          <a:prstGeom prst="rect">
+            <a:avLst/>
+          </a:prstGeom>
+          <a:ln w="38100" cap="sq">
+            <a:solidFill>
+              <a:srgbClr val="000000"/>
+            </a:solidFill>
+            <a:prstDash val="solid"/>
+            <a:miter lim="800000"/>
+          </a:ln>
+          <a:effectLst>
+            <a:outerShdw blurRad="50800" dist="38100" dir="2700000" algn="tl" rotWithShape="0">
+              <a:srgbClr val="000000">
+                <a:alpha val="43000"/>
+              </a:srgbClr>
+            </a:outerShdw>
+          </a:effectLst>
+        </p:spPr>
+      </p:pic>
+      <p:sp>
+        <p:nvSpPr>
+          <p:cNvPr id="4" name="Slide Number Placeholder 3">
+            <a:extLst>
+              <a:ext uri="{FF2B5EF4-FFF2-40B4-BE49-F238E27FC236}">
+                <a16:creationId xmlns:a16="http://schemas.microsoft.com/office/drawing/2014/main" id="{5BE71402-8979-D45A-6C10-C2C2473C3759}"/>
+              </a:ext>
+            </a:extLst>
+          </p:cNvPr>
+          <p:cNvSpPr>
+            <a:spLocks noGrp="1"/>
+          </p:cNvSpPr>
+          <p:nvPr>
+            <p:ph type="sldNum" sz="quarter" idx="15"/>
+          </p:nvPr>
+        </p:nvSpPr>
+        <p:spPr/>
+        <p:txBody>
+          <a:bodyPr/>
+          <a:lstStyle/>
+          <a:p>
+            <a:fld id="{18D65601-5AE2-46FC-B138-694DDD2B510D}" type="slidenum">
+              <a:rPr lang="en-US" smtClean="0"/>
+              <a:pPr/>
+              <a:t>4</a:t>
+            </a:fld>
+            <a:endParaRPr lang="en-US" dirty="0"/>
+          </a:p>
+        </p:txBody>
+      </p:sp>
+      <mc:AlternateContent xmlns:mc="http://schemas.openxmlformats.org/markup-compatibility/2006">
+        <mc:Choice xmlns:a14="http://schemas.microsoft.com/office/drawing/2010/main" Requires="a14">
+          <p:sp>
+            <p:nvSpPr>
+              <p:cNvPr id="7" name="Content Placeholder 2">
+                <a:extLst>
+                  <a:ext uri="{FF2B5EF4-FFF2-40B4-BE49-F238E27FC236}">
+                    <a16:creationId xmlns:a16="http://schemas.microsoft.com/office/drawing/2014/main" id="{8AEA13FE-9249-BC91-3DE3-D3D75802BD12}"/>
+                  </a:ext>
+                </a:extLst>
+              </p:cNvPr>
+              <p:cNvSpPr txBox="1">
+                <a:spLocks/>
+              </p:cNvSpPr>
+              <p:nvPr/>
+            </p:nvSpPr>
+            <p:spPr>
+              <a:xfrm>
+                <a:off x="1381117" y="1931437"/>
+                <a:ext cx="2845649" cy="4338734"/>
+              </a:xfrm>
+              <a:prstGeom prst="rect">
+                <a:avLst/>
+              </a:prstGeom>
+            </p:spPr>
+            <p:txBody>
+              <a:bodyPr vert="horz" lIns="0" tIns="0" rIns="0" bIns="0" rtlCol="0">
+                <a:normAutofit fontScale="25000" lnSpcReduction="20000"/>
+              </a:bodyPr>
+              <a:lstStyle>
+                <a:lvl1pPr marL="228600" indent="-228600" algn="l" defTabSz="914400" rtl="0" eaLnBrk="1" latinLnBrk="0" hangingPunct="1">
+                  <a:lnSpc>
+                    <a:spcPct val="100000"/>
+                  </a:lnSpc>
+                  <a:spcBef>
+                    <a:spcPts val="0"/>
+                  </a:spcBef>
+                  <a:spcAft>
+                    <a:spcPts val="1200"/>
+                  </a:spcAft>
+                  <a:buFont typeface="Arial" panose="020B0604020202020204" pitchFamily="34" charset="0"/>
+                  <a:buChar char="•"/>
+                  <a:defRPr sz="2000" kern="1200">
+                    <a:solidFill>
+                      <a:schemeClr val="tx1"/>
+                    </a:solidFill>
+                    <a:latin typeface="+mn-lt"/>
+                    <a:ea typeface="+mn-ea"/>
+                    <a:cs typeface="+mn-cs"/>
+                  </a:defRPr>
+                </a:lvl1pPr>
+                <a:lvl2pPr marL="685800" indent="-228600" algn="l" defTabSz="914400" rtl="0" eaLnBrk="1" latinLnBrk="0" hangingPunct="1">
+                  <a:lnSpc>
+                    <a:spcPct val="100000"/>
+                  </a:lnSpc>
+                  <a:spcBef>
+                    <a:spcPts val="0"/>
+                  </a:spcBef>
+                  <a:spcAft>
+                    <a:spcPts val="1200"/>
+                  </a:spcAft>
+                  <a:buFont typeface="Arial" panose="020B0604020202020204" pitchFamily="34" charset="0"/>
+                  <a:buChar char="•"/>
+                  <a:defRPr sz="2000" kern="1200">
+                    <a:solidFill>
+                      <a:schemeClr val="tx1"/>
+                    </a:solidFill>
+                    <a:latin typeface="+mn-lt"/>
+                    <a:ea typeface="+mn-ea"/>
+                    <a:cs typeface="+mn-cs"/>
+                  </a:defRPr>
+                </a:lvl2pPr>
+                <a:lvl3pPr marL="1143000" indent="-228600" algn="l" defTabSz="914400" rtl="0" eaLnBrk="1" latinLnBrk="0" hangingPunct="1">
+                  <a:lnSpc>
+                    <a:spcPct val="90000"/>
+                  </a:lnSpc>
+                  <a:spcBef>
+                    <a:spcPts val="0"/>
+                  </a:spcBef>
+                  <a:spcAft>
+                    <a:spcPts val="1200"/>
+                  </a:spcAft>
+                  <a:buFont typeface="Arial" panose="020B0604020202020204" pitchFamily="34" charset="0"/>
+                  <a:buChar char="•"/>
+                  <a:defRPr sz="2000" kern="1200">
+                    <a:solidFill>
+                      <a:schemeClr val="tx1"/>
+                    </a:solidFill>
+                    <a:latin typeface="+mn-lt"/>
+                    <a:ea typeface="+mn-ea"/>
+                    <a:cs typeface="+mn-cs"/>
+                  </a:defRPr>
+                </a:lvl3pPr>
+                <a:lvl4pPr marL="1600200" indent="-228600" algn="l" defTabSz="914400" rtl="0" eaLnBrk="1" latinLnBrk="0" hangingPunct="1">
+                  <a:lnSpc>
+                    <a:spcPct val="90000"/>
+                  </a:lnSpc>
+                  <a:spcBef>
+                    <a:spcPts val="0"/>
+                  </a:spcBef>
+                  <a:spcAft>
+                    <a:spcPts val="1200"/>
+                  </a:spcAft>
+                  <a:buFont typeface="Arial" panose="020B0604020202020204" pitchFamily="34" charset="0"/>
+                  <a:buChar char="•"/>
+                  <a:defRPr sz="2000" kern="1200">
+                    <a:solidFill>
+                      <a:schemeClr val="tx1"/>
+                    </a:solidFill>
+                    <a:latin typeface="+mn-lt"/>
+                    <a:ea typeface="+mn-ea"/>
+                    <a:cs typeface="+mn-cs"/>
+                  </a:defRPr>
+                </a:lvl4pPr>
+                <a:lvl5pPr marL="2057400" indent="-228600" algn="l" defTabSz="914400" rtl="0" eaLnBrk="1" latinLnBrk="0" hangingPunct="1">
+                  <a:lnSpc>
+                    <a:spcPct val="90000"/>
+                  </a:lnSpc>
+                  <a:spcBef>
+                    <a:spcPts val="0"/>
+                  </a:spcBef>
+                  <a:spcAft>
+                    <a:spcPts val="1200"/>
+                  </a:spcAft>
+                  <a:buFont typeface="Arial" panose="020B0604020202020204" pitchFamily="34" charset="0"/>
+                  <a:buChar char="•"/>
+                  <a:defRPr sz="2000" kern="1200">
+                    <a:solidFill>
+                      <a:schemeClr val="tx1"/>
+                    </a:solidFill>
+                    <a:latin typeface="+mn-lt"/>
+                    <a:ea typeface="+mn-ea"/>
+                    <a:cs typeface="+mn-cs"/>
+                  </a:defRPr>
+                </a:lvl5pPr>
+                <a:lvl6pPr marL="2514600" indent="-228600" algn="l" defTabSz="914400" rtl="0" eaLnBrk="1" latinLnBrk="0" hangingPunct="1">
+                  <a:lnSpc>
+                    <a:spcPct val="90000"/>
+                  </a:lnSpc>
+                  <a:spcBef>
+                    <a:spcPts val="500"/>
+                  </a:spcBef>
+                  <a:buFont typeface="Arial" panose="020B0604020202020204" pitchFamily="34" charset="0"/>
+                  <a:buChar char="•"/>
+                  <a:defRPr sz="1800" kern="1200">
+                    <a:solidFill>
+                      <a:schemeClr val="tx1"/>
+                    </a:solidFill>
+                    <a:latin typeface="+mn-lt"/>
+                    <a:ea typeface="+mn-ea"/>
+                    <a:cs typeface="+mn-cs"/>
+                  </a:defRPr>
+                </a:lvl6pPr>
+                <a:lvl7pPr marL="2971800" indent="-228600" algn="l" defTabSz="914400" rtl="0" eaLnBrk="1" latinLnBrk="0" hangingPunct="1">
+                  <a:lnSpc>
+                    <a:spcPct val="90000"/>
+                  </a:lnSpc>
+                  <a:spcBef>
+                    <a:spcPts val="500"/>
+                  </a:spcBef>
+                  <a:buFont typeface="Arial" panose="020B0604020202020204" pitchFamily="34" charset="0"/>
+                  <a:buChar char="•"/>
+                  <a:defRPr sz="1800" kern="1200">
+                    <a:solidFill>
+                      <a:schemeClr val="tx1"/>
+                    </a:solidFill>
+                    <a:latin typeface="+mn-lt"/>
+                    <a:ea typeface="+mn-ea"/>
+                    <a:cs typeface="+mn-cs"/>
+                  </a:defRPr>
+                </a:lvl7pPr>
+                <a:lvl8pPr marL="3429000" indent="-228600" algn="l" defTabSz="914400" rtl="0" eaLnBrk="1" latinLnBrk="0" hangingPunct="1">
+                  <a:lnSpc>
+                    <a:spcPct val="90000"/>
+                  </a:lnSpc>
+                  <a:spcBef>
+                    <a:spcPts val="500"/>
+                  </a:spcBef>
+                  <a:buFont typeface="Arial" panose="020B0604020202020204" pitchFamily="34" charset="0"/>
+                  <a:buChar char="•"/>
+                  <a:defRPr sz="1800" kern="1200">
+                    <a:solidFill>
+                      <a:schemeClr val="tx1"/>
+                    </a:solidFill>
+                    <a:latin typeface="+mn-lt"/>
+                    <a:ea typeface="+mn-ea"/>
+                    <a:cs typeface="+mn-cs"/>
+                  </a:defRPr>
+                </a:lvl8pPr>
+                <a:lvl9pPr marL="3886200" indent="-228600" algn="l" defTabSz="914400" rtl="0" eaLnBrk="1" latinLnBrk="0" hangingPunct="1">
+                  <a:lnSpc>
+                    <a:spcPct val="90000"/>
+                  </a:lnSpc>
+                  <a:spcBef>
+                    <a:spcPts val="500"/>
+                  </a:spcBef>
+                  <a:buFont typeface="Arial" panose="020B0604020202020204" pitchFamily="34" charset="0"/>
+                  <a:buChar char="•"/>
+                  <a:defRPr sz="1800" kern="1200">
+                    <a:solidFill>
+                      <a:schemeClr val="tx1"/>
+                    </a:solidFill>
+                    <a:latin typeface="+mn-lt"/>
+                    <a:ea typeface="+mn-ea"/>
+                    <a:cs typeface="+mn-cs"/>
+                  </a:defRPr>
+                </a:lvl9pPr>
+              </a:lstStyle>
+              <a:p>
+                <a:pPr marL="0" indent="0">
+                  <a:buFont typeface="Arial" panose="020B0604020202020204" pitchFamily="34" charset="0"/>
+                  <a:buNone/>
+                </a:pPr>
+                <a:r>
+                  <a:rPr lang="pl-PL" sz="9600" b="1" dirty="0">
+                    <a:latin typeface="Tisa Offc Serif Pro" panose="02010504030101020102" pitchFamily="2" charset="0"/>
+                  </a:rPr>
+                  <a:t>Finalny model</a:t>
+                </a:r>
+              </a:p>
+              <a:p>
+                <a:pPr marL="0" indent="0">
+                  <a:buNone/>
+                </a:pPr>
+                <a:r>
+                  <a:rPr lang="pl-PL" sz="6400" dirty="0">
+                    <a:latin typeface="Tisa Offc Serif Pro" panose="02010504030101020102" pitchFamily="2" charset="0"/>
+                  </a:rPr>
+                  <a:t>Sieć neuronowa samodzielnie rozbudowała się do 3 warstw o rozmiarach 64, 80 i 32 neuronów z aktywacją ReLU.</a:t>
+                </a:r>
+              </a:p>
+              <a:p>
+                <a:pPr marL="0" indent="0">
+                  <a:buNone/>
+                </a:pPr>
+                <a:r>
+                  <a:rPr lang="pl-PL" sz="6400" dirty="0">
+                    <a:latin typeface="Tisa Offc Serif Pro" panose="02010504030101020102" pitchFamily="2" charset="0"/>
+                  </a:rPr>
+                  <a:t>Współczynnik uczenia w końcowym etapie wyniósł </a:t>
+                </a:r>
+                <a14:m>
+                  <m:oMath xmlns:m="http://schemas.openxmlformats.org/officeDocument/2006/math">
+                    <m:r>
+                      <a:rPr lang="pl-PL" sz="6400" i="1">
+                        <a:latin typeface="+mj-lt"/>
+                      </a:rPr>
+                      <m:t>9</m:t>
+                    </m:r>
+                    <m:r>
+                      <a:rPr lang="pl-PL" sz="6400" b="0" i="1" smtClean="0">
+                        <a:latin typeface="+mj-lt"/>
+                      </a:rPr>
+                      <m:t>.8</m:t>
+                    </m:r>
+                    <m:r>
+                      <a:rPr lang="pl-PL" sz="6400" b="0" i="1" smtClean="0">
+                        <a:latin typeface="+mj-lt"/>
+                        <a:ea typeface="Cambria Math" panose="02040503050406030204" pitchFamily="18" charset="0"/>
+                      </a:rPr>
+                      <m:t>×</m:t>
+                    </m:r>
+                    <m:sSup>
+                      <m:sSupPr>
+                        <m:ctrlPr>
+                          <a:rPr lang="pl-PL" sz="6400" b="0" i="1" smtClean="0">
+                            <a:latin typeface="+mj-lt"/>
+                            <a:ea typeface="Cambria Math" panose="02040503050406030204" pitchFamily="18" charset="0"/>
+                          </a:rPr>
+                        </m:ctrlPr>
+                      </m:sSupPr>
+                      <m:e>
+                        <m:r>
+                          <a:rPr lang="pl-PL" sz="6400" b="0" i="1" smtClean="0">
+                            <a:latin typeface="+mj-lt"/>
+                            <a:ea typeface="Cambria Math" panose="02040503050406030204" pitchFamily="18" charset="0"/>
+                          </a:rPr>
+                          <m:t>10</m:t>
+                        </m:r>
+                      </m:e>
+                      <m:sup>
+                        <m:r>
+                          <a:rPr lang="pl-PL" sz="6400" b="0" i="1" smtClean="0">
+                            <a:latin typeface="+mj-lt"/>
+                            <a:ea typeface="Cambria Math" panose="02040503050406030204" pitchFamily="18" charset="0"/>
+                          </a:rPr>
+                          <m:t>−5</m:t>
+                        </m:r>
+                      </m:sup>
+                    </m:sSup>
+                  </m:oMath>
+                </a14:m>
+                <a:r>
+                  <a:rPr lang="pl-PL" sz="6400" dirty="0">
+                    <a:latin typeface="Tisa Offc Serif Pro" panose="02010504030101020102" pitchFamily="2" charset="0"/>
+                  </a:rPr>
+                  <a:t>.</a:t>
+                </a:r>
+              </a:p>
+              <a:p>
+                <a:pPr marL="0" indent="0">
+                  <a:buNone/>
+                </a:pPr>
+                <a:r>
+                  <a:rPr lang="pl-PL" sz="6400" dirty="0">
+                    <a:latin typeface="Tisa Offc Serif Pro" panose="02010504030101020102" pitchFamily="2" charset="0"/>
+                  </a:rPr>
+                  <a:t>Wielkość paczki danych (</a:t>
+                </a:r>
+                <a:r>
+                  <a:rPr lang="en-US" sz="6400" noProof="0" dirty="0">
+                    <a:latin typeface="Tisa Offc Serif Pro" panose="02010504030101020102" pitchFamily="2" charset="0"/>
+                  </a:rPr>
+                  <a:t>batch size</a:t>
+                </a:r>
+                <a:r>
+                  <a:rPr lang="pl-PL" sz="6400" dirty="0">
+                    <a:latin typeface="Tisa Offc Serif Pro" panose="02010504030101020102" pitchFamily="2" charset="0"/>
+                  </a:rPr>
+                  <a:t>) wzrosła do 564, a rozmiar kroku środowiska przybrał wartość 648.</a:t>
+                </a:r>
+              </a:p>
+            </p:txBody>
+          </p:sp>
+        </mc:Choice>
+        <mc:Fallback>
+          <p:sp>
+            <p:nvSpPr>
+              <p:cNvPr id="7" name="Content Placeholder 2">
+                <a:extLst>
+                  <a:ext uri="{FF2B5EF4-FFF2-40B4-BE49-F238E27FC236}">
+                    <a16:creationId xmlns:a16="http://schemas.microsoft.com/office/drawing/2014/main" id="{8AEA13FE-9249-BC91-3DE3-D3D75802BD12}"/>
+                  </a:ext>
+                </a:extLst>
+              </p:cNvPr>
+              <p:cNvSpPr txBox="1">
+                <a:spLocks noRot="1" noChangeAspect="1" noMove="1" noResize="1" noEditPoints="1" noAdjustHandles="1" noChangeArrowheads="1" noChangeShapeType="1" noTextEdit="1"/>
+              </p:cNvSpPr>
+              <p:nvPr/>
+            </p:nvSpPr>
+            <p:spPr>
+              <a:xfrm>
+                <a:off x="1381117" y="1931437"/>
+                <a:ext cx="2845649" cy="4338734"/>
+              </a:xfrm>
+              <a:prstGeom prst="rect">
+                <a:avLst/>
+              </a:prstGeom>
+              <a:blipFill>
+                <a:blip r:embed="rId3"/>
+                <a:stretch>
+                  <a:fillRect l="-6652" t="-3511" r="-3433"/>
+                </a:stretch>
+              </a:blipFill>
+            </p:spPr>
+            <p:txBody>
+              <a:bodyPr/>
+              <a:lstStyle/>
+              <a:p>
+                <a:r>
+                  <a:rPr lang="en-US">
+                    <a:noFill/>
+                  </a:rPr>
+                  <a:t> </a:t>
+                </a:r>
+              </a:p>
+            </p:txBody>
+          </p:sp>
+        </mc:Fallback>
+      </mc:AlternateContent>
+    </p:spTree>
+    <p:extLst>
+      <p:ext uri="{BB962C8B-B14F-4D97-AF65-F5344CB8AC3E}">
+        <p14:creationId xmlns:p14="http://schemas.microsoft.com/office/powerpoint/2010/main" val="3276679967"/>
+      </p:ext>
+    </p:extLst>
+  </p:cSld>
+  <p:clrMapOvr>
+    <a:masterClrMapping/>
+  </p:clrMapOvr>
+</p:sld>
+</file>
+
+<file path=ppt/slides/slide5.xml><?xml version="1.0" encoding="utf-8"?>
 <p:sld xmlns:a="http://schemas.openxmlformats.org/drawingml/2006/main" xmlns:r="http://schemas.openxmlformats.org/officeDocument/2006/relationships" xmlns:p="http://schemas.openxmlformats.org/presentationml/2006/main">
   <p:cSld>
     <p:spTree>
@@ -7074,14 +7507,14 @@
             <p:ph sz="quarter" idx="12"/>
             <p:extLst>
               <p:ext uri="{D42A27DB-BD31-4B8C-83A1-F6EECF244321}">
-                <p14:modId xmlns:p14="http://schemas.microsoft.com/office/powerpoint/2010/main" val="2115436867"/>
+                <p14:modId xmlns:p14="http://schemas.microsoft.com/office/powerpoint/2010/main" val="353419549"/>
               </p:ext>
             </p:extLst>
           </p:nvPr>
         </p:nvGraphicFramePr>
         <p:xfrm>
           <a:off x="1449388" y="2108200"/>
-          <a:ext cx="8553450" cy="2748280"/>
+          <a:ext cx="8553450" cy="2377440"/>
         </p:xfrm>
         <a:graphic>
           <a:graphicData uri="http://schemas.openxmlformats.org/drawingml/2006/table">
@@ -7090,14 +7523,14 @@
                 <a:tableStyleId>{0E3FDE45-AF77-4B5C-9715-49D594BDF05E}</a:tableStyleId>
               </a:tblPr>
               <a:tblGrid>
-                <a:gridCol w="2973322">
+                <a:gridCol w="2600098">
                   <a:extLst>
                     <a:ext uri="{9D8B030D-6E8A-4147-A177-3AD203B41FA5}">
                       <a16:colId xmlns:a16="http://schemas.microsoft.com/office/drawing/2014/main" val="2402208359"/>
                     </a:ext>
                   </a:extLst>
                 </a:gridCol>
-                <a:gridCol w="5580128">
+                <a:gridCol w="5953352">
                   <a:extLst>
                     <a:ext uri="{9D8B030D-6E8A-4147-A177-3AD203B41FA5}">
                       <a16:colId xmlns:a16="http://schemas.microsoft.com/office/drawing/2014/main" val="833629638"/>
@@ -7229,7 +7662,7 @@
                         <a:rPr lang="pl-PL" dirty="0">
                           <a:latin typeface="Tisa Offc Serif Pro" panose="02010504030101020102" pitchFamily="2" charset="0"/>
                         </a:rPr>
-                        <a:t>Silnik fizyczny gry oraz interfejs środowiska kompatybilny z OpenAI Gym.</a:t>
+                        <a:t>Oryginalny silnik fizyczny gry oraz interfejs środowiska kompatybilny z historycznym OpenAI Gym.</a:t>
                       </a:r>
                       <a:endParaRPr lang="en-US" dirty="0">
                         <a:latin typeface="Tisa Offc Serif Pro" panose="02010504030101020102" pitchFamily="2" charset="0"/>
@@ -7255,7 +7688,7 @@
                           <a:latin typeface="Tisa Offc Serif Pro" panose="02010504030101020102" pitchFamily="2" charset="0"/>
                           <a:hlinkClick r:id="rId4"/>
                         </a:rPr>
-                        <a:t>NumPy</a:t>
+                        <a:t>Gymnasium</a:t>
                       </a:r>
                       <a:endParaRPr lang="en-US" dirty="0">
                         <a:latin typeface="Tisa Offc Serif Pro" panose="02010504030101020102" pitchFamily="2" charset="0"/>
@@ -7273,7 +7706,7 @@
                         <a:rPr lang="pl-PL" dirty="0">
                           <a:latin typeface="Tisa Offc Serif Pro" panose="02010504030101020102" pitchFamily="2" charset="0"/>
                         </a:rPr>
-                        <a:t>Wydajne operacje macierzowe na wektorach stanu.</a:t>
+                        <a:t>Nowoczesna standard API dla agentowego uczenia ze wzmocnieniem zastępujący OpenAI Gym.</a:t>
                       </a:r>
                       <a:endParaRPr lang="en-US" dirty="0">
                         <a:latin typeface="Tisa Offc Serif Pro" panose="02010504030101020102" pitchFamily="2" charset="0"/>
@@ -7288,50 +7721,6 @@
                   </a:ext>
                 </a:extLst>
               </a:tr>
-              <a:tr h="370840">
-                <a:tc>
-                  <a:txBody>
-                    <a:bodyPr/>
-                    <a:lstStyle/>
-                    <a:p>
-                      <a:r>
-                        <a:rPr lang="en-US" dirty="0">
-                          <a:latin typeface="Tisa Offc Serif Pro" panose="02010504030101020102" pitchFamily="2" charset="0"/>
-                          <a:hlinkClick r:id="rId5"/>
-                        </a:rPr>
-                        <a:t>PyTorch / Stable-Baselines</a:t>
-                      </a:r>
-                      <a:endParaRPr lang="en-US" dirty="0">
-                        <a:latin typeface="Tisa Offc Serif Pro" panose="02010504030101020102" pitchFamily="2" charset="0"/>
-                      </a:endParaRPr>
-                    </a:p>
-                  </a:txBody>
-                  <a:tcPr/>
-                </a:tc>
-                <a:tc>
-                  <a:txBody>
-                    <a:bodyPr/>
-                    <a:lstStyle/>
-                    <a:p>
-                      <a:r>
-                        <a:rPr lang="pl-PL" dirty="0">
-                          <a:latin typeface="Tisa Offc Serif Pro" panose="02010504030101020102" pitchFamily="2" charset="0"/>
-                        </a:rPr>
-                        <a:t>Framework do budowy sieci neuronowych i zarządzania procesem uczenia.</a:t>
-                      </a:r>
-                      <a:endParaRPr lang="en-US" dirty="0">
-                        <a:latin typeface="Tisa Offc Serif Pro" panose="02010504030101020102" pitchFamily="2" charset="0"/>
-                      </a:endParaRPr>
-                    </a:p>
-                  </a:txBody>
-                  <a:tcPr/>
-                </a:tc>
-                <a:extLst>
-                  <a:ext uri="{0D108BD9-81ED-4DB2-BD59-A6C34878D82A}">
-                    <a16:rowId xmlns:a16="http://schemas.microsoft.com/office/drawing/2014/main" val="3143107506"/>
-                  </a:ext>
-                </a:extLst>
-              </a:tr>
             </a:tbl>
           </a:graphicData>
         </a:graphic>
@@ -7360,7 +7749,7 @@
             <a:fld id="{18D65601-5AE2-46FC-B138-694DDD2B510D}" type="slidenum">
               <a:rPr lang="pl-PL" noProof="0" smtClean="0"/>
               <a:pPr/>
-              <a:t>4</a:t>
+              <a:t>5</a:t>
             </a:fld>
             <a:endParaRPr lang="pl-PL" noProof="0" dirty="0"/>
           </a:p>
@@ -7379,7 +7768,7 @@
 </p:sld>
 </file>
 
-<file path=ppt/slides/slide5.xml><?xml version="1.0" encoding="utf-8"?>
+<file path=ppt/slides/slide6.xml><?xml version="1.0" encoding="utf-8"?>
 <p:sld xmlns:a="http://schemas.openxmlformats.org/drawingml/2006/main" xmlns:r="http://schemas.openxmlformats.org/officeDocument/2006/relationships" xmlns:p="http://schemas.openxmlformats.org/presentationml/2006/main">
   <p:cSld>
     <p:spTree>
@@ -7424,7 +7813,7 @@
           <a:p>
             <a:r>
               <a:rPr lang="pl-PL" dirty="0"/>
-              <a:t>Dziękuję za uwagę</a:t>
+              <a:t>Live Demo</a:t>
             </a:r>
             <a:endParaRPr lang="en-US" dirty="0"/>
           </a:p>
@@ -8284,15 +8673,6 @@
 </file>
 
 <file path=customXml/item2.xml><?xml version="1.0" encoding="utf-8"?>
-<?mso-contentType ?>
-<FormTemplates xmlns="http://schemas.microsoft.com/sharepoint/v3/contenttype/forms">
-  <Display>DocumentLibraryForm</Display>
-  <Edit>DocumentLibraryForm</Edit>
-  <New>DocumentLibraryForm</New>
-</FormTemplates>
-</file>
-
-<file path=customXml/item3.xml><?xml version="1.0" encoding="utf-8"?>
 <ct:contentTypeSchema xmlns:ct="http://schemas.microsoft.com/office/2006/metadata/contentType" xmlns:ma="http://schemas.microsoft.com/office/2006/metadata/properties/metaAttributes" ct:_="" ma:_="" ma:contentTypeName="Document" ma:contentTypeID="0x01010079F111ED35F8CC479449609E8A0923A6" ma:contentTypeVersion="28" ma:contentTypeDescription="Create a new document." ma:contentTypeScope="" ma:versionID="60f5a4f2d2b0abadcf532d48ebf9cb71">
   <xsd:schema xmlns:xsd="http://www.w3.org/2001/XMLSchema" xmlns:xs="http://www.w3.org/2001/XMLSchema" xmlns:p="http://schemas.microsoft.com/office/2006/metadata/properties" xmlns:ns1="http://schemas.microsoft.com/sharepoint/v3" xmlns:ns2="71af3243-3dd4-4a8d-8c0d-dd76da1f02a5" xmlns:ns3="16c05727-aa75-4e4a-9b5f-8a80a1165891" xmlns:ns4="230e9df3-be65-4c73-a93b-d1236ebd677e" targetNamespace="http://schemas.microsoft.com/office/2006/metadata/properties" ma:root="true" ma:fieldsID="7dd78129e6a1811f84807ad11c651531" ns1:_="" ns2:_="" ns3:_="" ns4:_="">
     <xsd:import namespace="http://schemas.microsoft.com/sharepoint/v3"/>
@@ -8604,6 +8984,15 @@
 </ct:contentTypeSchema>
 </file>
 
+<file path=customXml/item3.xml><?xml version="1.0" encoding="utf-8"?>
+<?mso-contentType ?>
+<FormTemplates xmlns="http://schemas.microsoft.com/sharepoint/v3/contenttype/forms">
+  <Display>DocumentLibraryForm</Display>
+  <Edit>DocumentLibraryForm</Edit>
+  <New>DocumentLibraryForm</New>
+</FormTemplates>
+</file>
+
 <file path=customXml/itemProps1.xml><?xml version="1.0" encoding="utf-8"?>
 <ds:datastoreItem xmlns:ds="http://schemas.openxmlformats.org/officeDocument/2006/customXml" ds:itemID="{3FDB7358-0BCB-4DEB-B717-C1D7CC555F05}">
   <ds:schemaRefs>
@@ -8617,14 +9006,6 @@
 </file>
 
 <file path=customXml/itemProps2.xml><?xml version="1.0" encoding="utf-8"?>
-<ds:datastoreItem xmlns:ds="http://schemas.openxmlformats.org/officeDocument/2006/customXml" ds:itemID="{6DE3707C-8CAB-4302-B7E1-D32E1543E05C}">
-  <ds:schemaRefs>
-    <ds:schemaRef ds:uri="http://schemas.microsoft.com/sharepoint/v3/contenttype/forms"/>
-  </ds:schemaRefs>
-</ds:datastoreItem>
-</file>
-
-<file path=customXml/itemProps3.xml><?xml version="1.0" encoding="utf-8"?>
 <ds:datastoreItem xmlns:ds="http://schemas.openxmlformats.org/officeDocument/2006/customXml" ds:itemID="{B69E9DE5-EFFE-4262-A023-32732F0B666C}">
   <ds:schemaRefs>
     <ds:schemaRef ds:uri="http://schemas.microsoft.com/office/2006/metadata/contentType"/>
@@ -8645,6 +9026,14 @@
 </ds:datastoreItem>
 </file>
 
+<file path=customXml/itemProps3.xml><?xml version="1.0" encoding="utf-8"?>
+<ds:datastoreItem xmlns:ds="http://schemas.openxmlformats.org/officeDocument/2006/customXml" ds:itemID="{6DE3707C-8CAB-4302-B7E1-D32E1543E05C}">
+  <ds:schemaRefs>
+    <ds:schemaRef ds:uri="http://schemas.microsoft.com/sharepoint/v3/contenttype/forms"/>
+  </ds:schemaRefs>
+</ds:datastoreItem>
+</file>
+
 <file path=docMetadata/LabelInfo.xml><?xml version="1.0" encoding="utf-8"?>
 <clbl:labelList xmlns:clbl="http://schemas.microsoft.com/office/2020/mipLabelMetadata"/>
 </file>
</xml_diff>